<commit_message>
harness: 100-case corpus, runner/validator, 5 templates + gallery, first 12-case pass
- tests/make_cases.py + cases.json (97 -> 100)
- tests/run_suite.py: new conversation per case, auth refresh, validation
- templates: themed manifests + previews; App style picker
- build_deck validates chart/table specs instead of silently skipping
- tests/results/SUITE-REPORT.md
</commit_message>
<xml_diff>
--- a/templates/corporate-2slide.pptx
+++ b/templates/corporate-2slide.pptx
@@ -274,7 +274,7 @@
             <a:r>
               <a:rPr lang="en-US" smtClean="0" sz="2000" b="0">
                 <a:solidFill>
-                  <a:srgbClr val="5A5A5A"/>
+                  <a:srgbClr val="333333"/>
                 </a:solidFill>
                 <a:latin typeface="Calibri"/>
               </a:rPr>
@@ -2496,9 +2496,12 @@
 <p:sldMaster xmlns:a="http://schemas.openxmlformats.org/drawingml/2006/main" xmlns:r="http://schemas.openxmlformats.org/officeDocument/2006/relationships" xmlns:p="http://schemas.openxmlformats.org/presentationml/2006/main">
   <p:cSld>
     <p:bg>
-      <p:bgRef idx="1001">
-        <a:schemeClr val="bg1"/>
-      </p:bgRef>
+      <p:bgPr>
+        <a:solidFill>
+          <a:srgbClr val="FFFFFF"/>
+        </a:solidFill>
+        <a:effectLst/>
+      </p:bgPr>
     </p:bg>
     <p:spTree>
       <p:nvGrpSpPr>
@@ -3027,7 +3030,14 @@
           <a:bodyPr/>
           <a:lstStyle/>
           <a:p>
-            <a:r>
+            <a:pPr algn="l"/>
+            <a:r>
+              <a:rPr sz="4000" b="1">
+                <a:solidFill>
+                  <a:srgbClr val="1F3864"/>
+                </a:solidFill>
+                <a:latin typeface="Calibri"/>
+              </a:rPr>
               <a:t>Presentation Title</a:t>
             </a:r>
           </a:p>
@@ -3048,7 +3058,14 @@
           <a:bodyPr/>
           <a:lstStyle/>
           <a:p>
-            <a:r>
+            <a:pPr algn="l"/>
+            <a:r>
+              <a:rPr sz="2000" b="0">
+                <a:solidFill>
+                  <a:srgbClr val="333333"/>
+                </a:solidFill>
+                <a:latin typeface="Calibri"/>
+              </a:rPr>
               <a:t>Subtitle or date</a:t>
             </a:r>
           </a:p>
@@ -3209,7 +3226,14 @@
           <a:bodyPr/>
           <a:lstStyle/>
           <a:p>
-            <a:r>
+            <a:pPr algn="l"/>
+            <a:r>
+              <a:rPr sz="2800" b="1">
+                <a:solidFill>
+                  <a:srgbClr val="1F3864"/>
+                </a:solidFill>
+                <a:latin typeface="Calibri"/>
+              </a:rPr>
               <a:t>Section Heading</a:t>
             </a:r>
           </a:p>
@@ -3230,19 +3254,38 @@
           <a:bodyPr/>
           <a:lstStyle/>
           <a:p>
-            <a:r>
+            <a:pPr algn="l"/>
+            <a:r>
+              <a:rPr sz="1900" b="0">
+                <a:solidFill>
+                  <a:srgbClr val="333333"/>
+                </a:solidFill>
+                <a:latin typeface="Calibri"/>
+              </a:rPr>
               <a:t>First key point</a:t>
             </a:r>
           </a:p>
           <a:p>
-            <a:pPr/>
-            <a:r>
+            <a:pPr algn="l"/>
+            <a:r>
+              <a:rPr sz="1900" b="0">
+                <a:solidFill>
+                  <a:srgbClr val="333333"/>
+                </a:solidFill>
+                <a:latin typeface="Calibri"/>
+              </a:rPr>
               <a:t>Second key point</a:t>
             </a:r>
           </a:p>
           <a:p>
-            <a:pPr/>
-            <a:r>
+            <a:pPr algn="l"/>
+            <a:r>
+              <a:rPr sz="1900" b="0">
+                <a:solidFill>
+                  <a:srgbClr val="333333"/>
+                </a:solidFill>
+                <a:latin typeface="Calibri"/>
+              </a:rPr>
               <a:t>Third key point</a:t>
             </a:r>
           </a:p>

</xml_diff>